<commit_message>
questions for self-control added
</commit_message>
<xml_diff>
--- a/2025/LEC/01-2 Модели ВР и постановка задачи.pptx
+++ b/2025/LEC/01-2 Модели ВР и постановка задачи.pptx
@@ -5,7 +5,7 @@
     <p:sldMasterId id="2147483672" r:id="rId1"/>
   </p:sldMasterIdLst>
   <p:notesMasterIdLst>
-    <p:notesMasterId r:id="rId32"/>
+    <p:notesMasterId r:id="rId29"/>
   </p:notesMasterIdLst>
   <p:sldIdLst>
     <p:sldId id="256" r:id="rId2"/>
@@ -29,15 +29,12 @@
     <p:sldId id="450" r:id="rId20"/>
     <p:sldId id="447" r:id="rId21"/>
     <p:sldId id="448" r:id="rId22"/>
-    <p:sldId id="440" r:id="rId23"/>
-    <p:sldId id="451" r:id="rId24"/>
-    <p:sldId id="437" r:id="rId25"/>
-    <p:sldId id="438" r:id="rId26"/>
-    <p:sldId id="439" r:id="rId27"/>
-    <p:sldId id="433" r:id="rId28"/>
-    <p:sldId id="434" r:id="rId29"/>
-    <p:sldId id="435" r:id="rId30"/>
-    <p:sldId id="436" r:id="rId31"/>
+    <p:sldId id="453" r:id="rId23"/>
+    <p:sldId id="440" r:id="rId24"/>
+    <p:sldId id="451" r:id="rId25"/>
+    <p:sldId id="437" r:id="rId26"/>
+    <p:sldId id="438" r:id="rId27"/>
+    <p:sldId id="439" r:id="rId28"/>
   </p:sldIdLst>
   <p:sldSz cx="12192000" cy="6858000"/>
   <p:notesSz cx="6858000" cy="9144000"/>
@@ -226,7 +223,7 @@
           <a:p>
             <a:fld id="{CDA96C9A-3213-B245-BC64-7E419D14BD9D}" type="datetimeFigureOut">
               <a:rPr lang="ru-RU" smtClean="0"/>
-              <a:t>21.07.2025</a:t>
+              <a:t>20.08.2025</a:t>
             </a:fld>
             <a:endParaRPr lang="ru-RU"/>
           </a:p>
@@ -726,7 +723,7 @@
           <a:p>
             <a:fld id="{9DA1EE30-E435-D745-B23A-FF31C831763F}" type="slidenum">
               <a:rPr lang="ru-RU" smtClean="0"/>
-              <a:t>22</a:t>
+              <a:t>23</a:t>
             </a:fld>
             <a:endParaRPr lang="ru-RU"/>
           </a:p>
@@ -810,7 +807,7 @@
           <a:p>
             <a:fld id="{9DA1EE30-E435-D745-B23A-FF31C831763F}" type="slidenum">
               <a:rPr lang="ru-RU" smtClean="0"/>
-              <a:t>23</a:t>
+              <a:t>24</a:t>
             </a:fld>
             <a:endParaRPr lang="ru-RU"/>
           </a:p>
@@ -960,7 +957,7 @@
           <a:p>
             <a:fld id="{BEE214BE-636D-8A45-BCA6-8B7ED77AA124}" type="datetime1">
               <a:rPr lang="ru-RU" smtClean="0"/>
-              <a:t>21.07.2025</a:t>
+              <a:t>20.08.2025</a:t>
             </a:fld>
             <a:endParaRPr lang="en-US"/>
           </a:p>
@@ -1130,7 +1127,7 @@
           <a:p>
             <a:fld id="{5855274A-4ED4-0146-A3E9-88EF200B5196}" type="datetime1">
               <a:rPr lang="ru-RU" smtClean="0"/>
-              <a:t>21.07.2025</a:t>
+              <a:t>20.08.2025</a:t>
             </a:fld>
             <a:endParaRPr lang="en-US"/>
           </a:p>
@@ -1310,7 +1307,7 @@
           <a:p>
             <a:fld id="{8A78DFF1-9FDC-144B-973E-B4B4609709DF}" type="datetime1">
               <a:rPr lang="ru-RU" smtClean="0"/>
-              <a:t>21.07.2025</a:t>
+              <a:t>20.08.2025</a:t>
             </a:fld>
             <a:endParaRPr lang="en-US"/>
           </a:p>
@@ -1480,7 +1477,7 @@
           <a:p>
             <a:fld id="{8233A339-F8AE-5C45-BEAE-07EF9DC78B60}" type="datetime1">
               <a:rPr lang="ru-RU" smtClean="0"/>
-              <a:t>21.07.2025</a:t>
+              <a:t>20.08.2025</a:t>
             </a:fld>
             <a:endParaRPr lang="en-US"/>
           </a:p>
@@ -1726,7 +1723,7 @@
           <a:p>
             <a:fld id="{7586FDE4-97E0-CE4A-988C-F30B221290A7}" type="datetime1">
               <a:rPr lang="ru-RU" smtClean="0"/>
-              <a:t>21.07.2025</a:t>
+              <a:t>20.08.2025</a:t>
             </a:fld>
             <a:endParaRPr lang="en-US"/>
           </a:p>
@@ -1958,7 +1955,7 @@
           <a:p>
             <a:fld id="{C36ECE8B-8DEC-154E-9F03-047C8DDA20DC}" type="datetime1">
               <a:rPr lang="ru-RU" smtClean="0"/>
-              <a:t>21.07.2025</a:t>
+              <a:t>20.08.2025</a:t>
             </a:fld>
             <a:endParaRPr lang="en-US"/>
           </a:p>
@@ -2325,7 +2322,7 @@
           <a:p>
             <a:fld id="{440816D5-BDB8-B34B-8ACA-ECBDD12E7321}" type="datetime1">
               <a:rPr lang="ru-RU" smtClean="0"/>
-              <a:t>21.07.2025</a:t>
+              <a:t>20.08.2025</a:t>
             </a:fld>
             <a:endParaRPr lang="en-US"/>
           </a:p>
@@ -2443,7 +2440,7 @@
           <a:p>
             <a:fld id="{8A8C589A-5627-764C-AF96-C1E2F9A00A4D}" type="datetime1">
               <a:rPr lang="ru-RU" smtClean="0"/>
-              <a:t>21.07.2025</a:t>
+              <a:t>20.08.2025</a:t>
             </a:fld>
             <a:endParaRPr lang="en-US"/>
           </a:p>
@@ -2538,7 +2535,7 @@
           <a:p>
             <a:fld id="{603EE0D0-1696-6D4F-B917-4AFB24A74E8B}" type="datetime1">
               <a:rPr lang="ru-RU" smtClean="0"/>
-              <a:t>21.07.2025</a:t>
+              <a:t>20.08.2025</a:t>
             </a:fld>
             <a:endParaRPr lang="en-US"/>
           </a:p>
@@ -2815,7 +2812,7 @@
           <a:p>
             <a:fld id="{13C8A91E-B09B-2240-9AA3-B1D4BCC6296E}" type="datetime1">
               <a:rPr lang="ru-RU" smtClean="0"/>
-              <a:t>21.07.2025</a:t>
+              <a:t>20.08.2025</a:t>
             </a:fld>
             <a:endParaRPr lang="en-US"/>
           </a:p>
@@ -3072,7 +3069,7 @@
           <a:p>
             <a:fld id="{3BE9760E-DA8D-6747-B31E-62858C8727B8}" type="datetime1">
               <a:rPr lang="ru-RU" smtClean="0"/>
-              <a:t>21.07.2025</a:t>
+              <a:t>20.08.2025</a:t>
             </a:fld>
             <a:endParaRPr lang="en-US"/>
           </a:p>
@@ -3285,7 +3282,7 @@
           <a:p>
             <a:fld id="{D31305DF-F750-CC43-967D-51A20925EE94}" type="datetime1">
               <a:rPr lang="ru-RU" smtClean="0"/>
-              <a:t>21.07.2025</a:t>
+              <a:t>20.08.2025</a:t>
             </a:fld>
             <a:endParaRPr lang="en-US"/>
           </a:p>
@@ -7722,8 +7719,8 @@
           </a:ln>
         </p:spPr>
       </p:pic>
-      <mc:AlternateContent xmlns:mc="http://schemas.openxmlformats.org/markup-compatibility/2006" xmlns:a14="http://schemas.microsoft.com/office/drawing/2010/main">
-        <mc:Choice Requires="a14">
+      <mc:AlternateContent xmlns:mc="http://schemas.openxmlformats.org/markup-compatibility/2006">
+        <mc:Choice xmlns:a14="http://schemas.microsoft.com/office/drawing/2010/main" Requires="a14">
           <p:sp>
             <p:nvSpPr>
               <p:cNvPr id="6" name="Прямоугольник 5"/>
@@ -7733,7 +7730,7 @@
             <p:spPr>
               <a:xfrm>
                 <a:off x="354110" y="4331961"/>
-                <a:ext cx="7934234" cy="1415324"/>
+                <a:ext cx="7934234" cy="1744645"/>
               </a:xfrm>
               <a:prstGeom prst="rect">
                 <a:avLst/>
@@ -7754,8 +7751,12 @@
                   </a:spcAft>
                 </a:pPr>
                 <a:r>
+                  <a:rPr lang="ru-RU" sz="2000" b="1" dirty="0" smtClean="0"/>
+                  <a:t>Вероятностный </a:t>
+                </a:r>
+                <a:r>
                   <a:rPr lang="ru-RU" sz="2000" b="1" dirty="0"/>
-                  <a:t>Интервальный прогноз</a:t>
+                  <a:t>прогноз</a:t>
                 </a:r>
                 <a:r>
                   <a:rPr lang="en-US" sz="2000" b="1" dirty="0"/>
@@ -7763,7 +7764,15 @@
                 </a:r>
                 <a:r>
                   <a:rPr lang="ru-RU" sz="2000" dirty="0"/>
-                  <a:t>- комбинация двух предыдущих. Задача заключается в предсказании интервала, в который попадёт </a:t>
+                  <a:t>- комбинация двух предыдущих. </a:t>
+                </a:r>
+                <a:r>
+                  <a:rPr lang="ru-RU" sz="2000" dirty="0" smtClean="0"/>
+                  <a:t>Есть разные варианты, например интервальный прогноз - Задача </a:t>
+                </a:r>
+                <a:r>
+                  <a:rPr lang="ru-RU" sz="2000" dirty="0"/>
+                  <a:t>заключается в предсказании интервала, в который попадёт </a:t>
                 </a:r>
                 <a14:m>
                   <m:oMath xmlns:m="http://schemas.openxmlformats.org/officeDocument/2006/math">
@@ -7938,7 +7947,7 @@
             </p:txBody>
           </p:sp>
         </mc:Choice>
-        <mc:Fallback xmlns="">
+        <mc:Fallback>
           <p:sp>
             <p:nvSpPr>
               <p:cNvPr id="6" name="Прямоугольник 5"/>
@@ -7950,7 +7959,7 @@
             <p:spPr>
               <a:xfrm>
                 <a:off x="354110" y="4331961"/>
-                <a:ext cx="7934234" cy="1415324"/>
+                <a:ext cx="7934234" cy="1744645"/>
               </a:xfrm>
               <a:prstGeom prst="rect">
                 <a:avLst/>
@@ -7958,7 +7967,7 @@
               <a:blipFill>
                 <a:blip r:embed="rId4"/>
                 <a:stretch>
-                  <a:fillRect l="-768" t="-2155" b="-5603"/>
+                  <a:fillRect l="-768" t="-1748" b="-4545"/>
                 </a:stretch>
               </a:blipFill>
             </p:spPr>
@@ -10619,8 +10628,8 @@
         </p:nvSpPr>
         <p:spPr>
           <a:xfrm>
-            <a:off x="126236" y="1036503"/>
-            <a:ext cx="7312789" cy="5611947"/>
+            <a:off x="102790" y="937510"/>
+            <a:ext cx="7312789" cy="5783965"/>
           </a:xfrm>
         </p:spPr>
         <p:txBody>
@@ -10630,7 +10639,7 @@
           <a:lstStyle/>
           <a:p>
             <a:r>
-              <a:rPr lang="ru-RU" sz="2400" dirty="0"/>
+              <a:rPr lang="ru-RU" sz="2400" b="1" dirty="0"/>
               <a:t>Как устроен ВР </a:t>
             </a:r>
           </a:p>
@@ -10713,9 +10722,26 @@
           </a:p>
           <a:p>
             <a:r>
+              <a:rPr lang="ru-RU" sz="2400" b="1" dirty="0" smtClean="0"/>
+              <a:t>Переменная </a:t>
+            </a:r>
+            <a:r>
               <a:rPr lang="ru-RU" sz="2400" b="1" dirty="0"/>
-              <a:t>Переменная для предсказания  </a:t>
-            </a:r>
+              <a:t>для предсказания  </a:t>
+            </a:r>
+            <a:r>
+              <a:rPr lang="ru-RU" sz="2400" b="1" dirty="0"/>
+              <a:t>(Диагностика </a:t>
+            </a:r>
+            <a:r>
+              <a:rPr lang="ru-RU" sz="2400" b="1" dirty="0" smtClean="0"/>
+              <a:t>ВР</a:t>
+            </a:r>
+            <a:r>
+              <a:rPr lang="ru-RU" sz="2400" b="1" dirty="0"/>
+              <a:t>)</a:t>
+            </a:r>
+            <a:endParaRPr lang="ru-RU" sz="2400" b="1" dirty="0"/>
           </a:p>
           <a:p>
             <a:pPr lvl="1"/>
@@ -11241,6 +11267,161 @@
 </file>
 
 <file path=ppt/slides/slide22.xml><?xml version="1.0" encoding="utf-8"?>
+<p:sld xmlns:a="http://schemas.openxmlformats.org/drawingml/2006/main" xmlns:r="http://schemas.openxmlformats.org/officeDocument/2006/relationships" xmlns:p="http://schemas.openxmlformats.org/presentationml/2006/main">
+  <p:cSld>
+    <p:spTree>
+      <p:nvGrpSpPr>
+        <p:cNvPr id="1" name=""/>
+        <p:cNvGrpSpPr/>
+        <p:nvPr/>
+      </p:nvGrpSpPr>
+      <p:grpSpPr>
+        <a:xfrm>
+          <a:off x="0" y="0"/>
+          <a:ext cx="0" cy="0"/>
+          <a:chOff x="0" y="0"/>
+          <a:chExt cx="0" cy="0"/>
+        </a:xfrm>
+      </p:grpSpPr>
+      <p:sp>
+        <p:nvSpPr>
+          <p:cNvPr id="2" name="Заголовок 1"/>
+          <p:cNvSpPr>
+            <a:spLocks noGrp="1"/>
+          </p:cNvSpPr>
+          <p:nvPr>
+            <p:ph type="title"/>
+          </p:nvPr>
+        </p:nvSpPr>
+        <p:spPr>
+          <a:xfrm>
+            <a:off x="331470" y="365125"/>
+            <a:ext cx="11022330" cy="743585"/>
+          </a:xfrm>
+        </p:spPr>
+        <p:txBody>
+          <a:bodyPr/>
+          <a:lstStyle/>
+          <a:p>
+            <a:r>
+              <a:rPr lang="ru-RU" dirty="0" smtClean="0"/>
+              <a:t>Вопросы для самоконтроля</a:t>
+            </a:r>
+            <a:endParaRPr lang="ru-RU" dirty="0"/>
+          </a:p>
+        </p:txBody>
+      </p:sp>
+      <p:sp>
+        <p:nvSpPr>
+          <p:cNvPr id="3" name="Объект 2"/>
+          <p:cNvSpPr>
+            <a:spLocks noGrp="1"/>
+          </p:cNvSpPr>
+          <p:nvPr>
+            <p:ph idx="1"/>
+          </p:nvPr>
+        </p:nvSpPr>
+        <p:spPr>
+          <a:xfrm>
+            <a:off x="331470" y="1211580"/>
+            <a:ext cx="11022330" cy="5509895"/>
+          </a:xfrm>
+        </p:spPr>
+        <p:txBody>
+          <a:bodyPr>
+            <a:normAutofit/>
+          </a:bodyPr>
+          <a:lstStyle/>
+          <a:p>
+            <a:pPr lvl="0"/>
+            <a:r>
+              <a:rPr lang="ru-RU" sz="2400" dirty="0"/>
+              <a:t>Назовите основные компоненты ВР. Приведите примеры ВР с различным поведением каждой из компонент. Как компоненты повлияют на результаты прогноза ВР. Попробуйте визуализировать пример модели с разными соотношениями компонент.</a:t>
+            </a:r>
+          </a:p>
+          <a:p>
+            <a:r>
+              <a:rPr lang="ru-RU" sz="2400" dirty="0" smtClean="0"/>
+              <a:t>Опишите выражения моделей с регулярным трендом и сезонностью. Как можно добавить в эту модель редкие но регулярные факторы? Как в модели проявятся аномалии. </a:t>
+            </a:r>
+          </a:p>
+          <a:p>
+            <a:pPr lvl="0"/>
+            <a:r>
+              <a:rPr lang="ru-RU" sz="2400" dirty="0"/>
+              <a:t> </a:t>
+            </a:r>
+            <a:r>
+              <a:rPr lang="ru-RU" sz="2400" dirty="0"/>
+              <a:t>Объясните необходимость задач вероятностного прогнозирования ВР. Приведите примеры задач где это важно. </a:t>
+            </a:r>
+          </a:p>
+          <a:p>
+            <a:r>
+              <a:rPr lang="ru-RU" sz="2400" smtClean="0"/>
+              <a:t>Выберите </a:t>
+            </a:r>
+            <a:r>
+              <a:rPr lang="ru-RU" sz="2400" dirty="0" smtClean="0"/>
+              <a:t>задачу и проведите анализ </a:t>
+            </a:r>
+            <a:r>
+              <a:rPr lang="ru-RU" sz="2400" smtClean="0"/>
+              <a:t>и постановку задачи для нее.</a:t>
+            </a:r>
+            <a:endParaRPr lang="ru-RU" sz="2400" dirty="0" smtClean="0"/>
+          </a:p>
+          <a:p>
+            <a:endParaRPr lang="ru-RU" sz="2400" dirty="0"/>
+          </a:p>
+          <a:p>
+            <a:endParaRPr lang="ru-RU" sz="2400" dirty="0" smtClean="0"/>
+          </a:p>
+          <a:p>
+            <a:endParaRPr lang="ru-RU" sz="2400" dirty="0" smtClean="0"/>
+          </a:p>
+          <a:p>
+            <a:endParaRPr lang="ru-RU" sz="2400" dirty="0"/>
+          </a:p>
+        </p:txBody>
+      </p:sp>
+      <p:sp>
+        <p:nvSpPr>
+          <p:cNvPr id="4" name="Номер слайда 3"/>
+          <p:cNvSpPr>
+            <a:spLocks noGrp="1"/>
+          </p:cNvSpPr>
+          <p:nvPr>
+            <p:ph type="sldNum" sz="quarter" idx="12"/>
+          </p:nvPr>
+        </p:nvSpPr>
+        <p:spPr/>
+        <p:txBody>
+          <a:bodyPr/>
+          <a:lstStyle/>
+          <a:p>
+            <a:fld id="{45C3B737-A709-4ABC-AFE0-A6B067850C48}" type="slidenum">
+              <a:rPr lang="en-US" smtClean="0"/>
+              <a:t>22</a:t>
+            </a:fld>
+            <a:endParaRPr lang="en-US"/>
+          </a:p>
+        </p:txBody>
+      </p:sp>
+    </p:spTree>
+    <p:extLst>
+      <p:ext uri="{BB962C8B-B14F-4D97-AF65-F5344CB8AC3E}">
+        <p14:creationId xmlns:p14="http://schemas.microsoft.com/office/powerpoint/2010/main" val="1738669824"/>
+      </p:ext>
+    </p:extLst>
+  </p:cSld>
+  <p:clrMapOvr>
+    <a:masterClrMapping/>
+  </p:clrMapOvr>
+</p:sld>
+</file>
+
+<file path=ppt/slides/slide23.xml><?xml version="1.0" encoding="utf-8"?>
 <p:sld xmlns:a="http://schemas.openxmlformats.org/drawingml/2006/main" xmlns:r="http://schemas.openxmlformats.org/officeDocument/2006/relationships" xmlns:p="http://schemas.openxmlformats.org/presentationml/2006/main" show="0">
   <p:cSld>
     <p:spTree>
@@ -11327,7 +11508,7 @@
           <a:p>
             <a:fld id="{45C3B737-A709-4ABC-AFE0-A6B067850C48}" type="slidenum">
               <a:rPr lang="en-US" smtClean="0"/>
-              <a:t>22</a:t>
+              <a:t>23</a:t>
             </a:fld>
             <a:endParaRPr lang="en-US"/>
           </a:p>
@@ -11670,7 +11851,7 @@
 </p:sld>
 </file>
 
-<file path=ppt/slides/slide23.xml><?xml version="1.0" encoding="utf-8"?>
+<file path=ppt/slides/slide24.xml><?xml version="1.0" encoding="utf-8"?>
 <p:sld xmlns:a="http://schemas.openxmlformats.org/drawingml/2006/main" xmlns:r="http://schemas.openxmlformats.org/officeDocument/2006/relationships" xmlns:p="http://schemas.openxmlformats.org/presentationml/2006/main" show="0">
   <p:cSld>
     <p:spTree>
@@ -11734,7 +11915,7 @@
           <a:p>
             <a:fld id="{45C3B737-A709-4ABC-AFE0-A6B067850C48}" type="slidenum">
               <a:rPr lang="en-US" smtClean="0"/>
-              <a:t>23</a:t>
+              <a:t>24</a:t>
             </a:fld>
             <a:endParaRPr lang="en-US" dirty="0"/>
           </a:p>
@@ -11830,7 +12011,7 @@
 </p:sld>
 </file>
 
-<file path=ppt/slides/slide24.xml><?xml version="1.0" encoding="utf-8"?>
+<file path=ppt/slides/slide25.xml><?xml version="1.0" encoding="utf-8"?>
 <p:sld xmlns:a="http://schemas.openxmlformats.org/drawingml/2006/main" xmlns:r="http://schemas.openxmlformats.org/officeDocument/2006/relationships" xmlns:p="http://schemas.openxmlformats.org/presentationml/2006/main" show="0">
   <p:cSld>
     <p:spTree>
@@ -11906,7 +12087,7 @@
           <a:p>
             <a:fld id="{45C3B737-A709-4ABC-AFE0-A6B067850C48}" type="slidenum">
               <a:rPr lang="en-US" smtClean="0"/>
-              <a:t>24</a:t>
+              <a:t>25</a:t>
             </a:fld>
             <a:endParaRPr lang="en-US"/>
           </a:p>
@@ -12002,7 +12183,7 @@
 </p:sld>
 </file>
 
-<file path=ppt/slides/slide25.xml><?xml version="1.0" encoding="utf-8"?>
+<file path=ppt/slides/slide26.xml><?xml version="1.0" encoding="utf-8"?>
 <p:sld xmlns:a="http://schemas.openxmlformats.org/drawingml/2006/main" xmlns:r="http://schemas.openxmlformats.org/officeDocument/2006/relationships" xmlns:p="http://schemas.openxmlformats.org/presentationml/2006/main" show="0">
   <p:cSld>
     <p:spTree>
@@ -12087,7 +12268,7 @@
           <a:p>
             <a:fld id="{45C3B737-A709-4ABC-AFE0-A6B067850C48}" type="slidenum">
               <a:rPr lang="en-US" smtClean="0"/>
-              <a:t>25</a:t>
+              <a:t>26</a:t>
             </a:fld>
             <a:endParaRPr lang="en-US"/>
           </a:p>
@@ -12181,7 +12362,7 @@
 </p:sld>
 </file>
 
-<file path=ppt/slides/slide26.xml><?xml version="1.0" encoding="utf-8"?>
+<file path=ppt/slides/slide27.xml><?xml version="1.0" encoding="utf-8"?>
 <p:sld xmlns:a="http://schemas.openxmlformats.org/drawingml/2006/main" xmlns:r="http://schemas.openxmlformats.org/officeDocument/2006/relationships" xmlns:p="http://schemas.openxmlformats.org/presentationml/2006/main" show="0">
   <p:cSld>
     <p:spTree>
@@ -12256,7 +12437,7 @@
           <a:p>
             <a:fld id="{45C3B737-A709-4ABC-AFE0-A6B067850C48}" type="slidenum">
               <a:rPr lang="en-US" smtClean="0"/>
-              <a:t>26</a:t>
+              <a:t>27</a:t>
             </a:fld>
             <a:endParaRPr lang="en-US"/>
           </a:p>
@@ -12363,763 +12544,6 @@
     <p:extLst>
       <p:ext uri="{BB962C8B-B14F-4D97-AF65-F5344CB8AC3E}">
         <p14:creationId xmlns:p14="http://schemas.microsoft.com/office/powerpoint/2010/main" val="875773777"/>
-      </p:ext>
-    </p:extLst>
-  </p:cSld>
-  <p:clrMapOvr>
-    <a:masterClrMapping/>
-  </p:clrMapOvr>
-  <mc:AlternateContent xmlns:mc="http://schemas.openxmlformats.org/markup-compatibility/2006" xmlns:p14="http://schemas.microsoft.com/office/powerpoint/2010/main">
-    <mc:Choice Requires="p14">
-      <p:transition spd="slow" p14:dur="2000"/>
-    </mc:Choice>
-    <mc:Fallback xmlns="">
-      <p:transition spd="slow"/>
-    </mc:Fallback>
-  </mc:AlternateContent>
-</p:sld>
-</file>
-
-<file path=ppt/slides/slide27.xml><?xml version="1.0" encoding="utf-8"?>
-<p:sld xmlns:a="http://schemas.openxmlformats.org/drawingml/2006/main" xmlns:r="http://schemas.openxmlformats.org/officeDocument/2006/relationships" xmlns:p="http://schemas.openxmlformats.org/presentationml/2006/main" show="0">
-  <p:cSld>
-    <p:spTree>
-      <p:nvGrpSpPr>
-        <p:cNvPr id="1" name=""/>
-        <p:cNvGrpSpPr/>
-        <p:nvPr/>
-      </p:nvGrpSpPr>
-      <p:grpSpPr>
-        <a:xfrm>
-          <a:off x="0" y="0"/>
-          <a:ext cx="0" cy="0"/>
-          <a:chOff x="0" y="0"/>
-          <a:chExt cx="0" cy="0"/>
-        </a:xfrm>
-      </p:grpSpPr>
-      <p:sp>
-        <p:nvSpPr>
-          <p:cNvPr id="2" name="Заголовок 1"/>
-          <p:cNvSpPr>
-            <a:spLocks noGrp="1"/>
-          </p:cNvSpPr>
-          <p:nvPr>
-            <p:ph type="title"/>
-          </p:nvPr>
-        </p:nvSpPr>
-        <p:spPr>
-          <a:xfrm>
-            <a:off x="244366" y="365125"/>
-            <a:ext cx="11109434" cy="628103"/>
-          </a:xfrm>
-        </p:spPr>
-        <p:txBody>
-          <a:bodyPr>
-            <a:normAutofit fontScale="90000"/>
-          </a:bodyPr>
-          <a:lstStyle/>
-          <a:p>
-            <a:r>
-              <a:rPr lang="ru-RU" dirty="0"/>
-              <a:t>Литература</a:t>
-            </a:r>
-          </a:p>
-        </p:txBody>
-      </p:sp>
-      <p:sp>
-        <p:nvSpPr>
-          <p:cNvPr id="3" name="Объект 2"/>
-          <p:cNvSpPr>
-            <a:spLocks noGrp="1"/>
-          </p:cNvSpPr>
-          <p:nvPr>
-            <p:ph idx="1"/>
-          </p:nvPr>
-        </p:nvSpPr>
-        <p:spPr>
-          <a:xfrm>
-            <a:off x="165538" y="993228"/>
-            <a:ext cx="11737428" cy="5363122"/>
-          </a:xfrm>
-        </p:spPr>
-        <p:txBody>
-          <a:bodyPr/>
-          <a:lstStyle/>
-          <a:p>
-            <a:r>
-              <a:rPr lang="en-US" b="1" dirty="0"/>
-              <a:t>Forecasting: Principles and Practice, the </a:t>
-            </a:r>
-            <a:r>
-              <a:rPr lang="en-US" b="1" dirty="0" err="1"/>
-              <a:t>Pythonic</a:t>
-            </a:r>
-            <a:r>
-              <a:rPr lang="en-US" b="1" dirty="0"/>
-              <a:t> Way - </a:t>
-            </a:r>
-            <a:r>
-              <a:rPr lang="en-US" dirty="0">
-                <a:hlinkClick r:id="rId2"/>
-              </a:rPr>
-              <a:t>https://otexts.com/fpppy/</a:t>
-            </a:r>
-            <a:r>
-              <a:rPr lang="en-US" dirty="0"/>
-              <a:t> (2025 </a:t>
-            </a:r>
-            <a:r>
-              <a:rPr lang="ru-RU" dirty="0"/>
-              <a:t>год)</a:t>
-            </a:r>
-          </a:p>
-          <a:p>
-            <a:r>
-              <a:rPr lang="ru-RU" dirty="0"/>
-              <a:t>Переработка </a:t>
-            </a:r>
-            <a:r>
-              <a:rPr lang="ru-RU" dirty="0" err="1"/>
-              <a:t>fpp</a:t>
-            </a:r>
-            <a:r>
-              <a:rPr lang="en-US" dirty="0"/>
-              <a:t>3</a:t>
-            </a:r>
-            <a:r>
-              <a:rPr lang="ru-RU" dirty="0"/>
-              <a:t> (</a:t>
-            </a:r>
-            <a:r>
-              <a:rPr lang="en" u="sng" dirty="0">
-                <a:hlinkClick r:id="rId3"/>
-              </a:rPr>
-              <a:t>https://otexts.com/fpp3/</a:t>
-            </a:r>
-            <a:r>
-              <a:rPr lang="ru-RU" dirty="0"/>
-              <a:t>)</a:t>
-            </a:r>
-            <a:r>
-              <a:rPr lang="en-US" dirty="0"/>
-              <a:t> </a:t>
-            </a:r>
-            <a:r>
-              <a:rPr lang="ru-RU" dirty="0"/>
-              <a:t>на </a:t>
-            </a:r>
-            <a:r>
-              <a:rPr lang="en-US" dirty="0"/>
-              <a:t>python </a:t>
-            </a:r>
-            <a:r>
-              <a:rPr lang="en-US" dirty="0">
-                <a:hlinkClick r:id="rId4"/>
-              </a:rPr>
-              <a:t>https://github.com/zgana/fpp3-python-readalong/tree/master</a:t>
-            </a:r>
-            <a:r>
-              <a:rPr lang="en-US" dirty="0"/>
-              <a:t>  </a:t>
-            </a:r>
-            <a:r>
-              <a:rPr lang="ru-RU" dirty="0"/>
-              <a:t>и тут </a:t>
-            </a:r>
-            <a:r>
-              <a:rPr lang="en" dirty="0">
-                <a:hlinkClick r:id="rId5"/>
-              </a:rPr>
-              <a:t>https://f0nzie.github.io/hyndman-bookdown-rsuite/</a:t>
-            </a:r>
-            <a:r>
-              <a:rPr lang="ru-RU" dirty="0"/>
-              <a:t> </a:t>
-            </a:r>
-          </a:p>
-          <a:p>
-            <a:r>
-              <a:rPr lang="en" dirty="0">
-                <a:hlinkClick r:id="rId6"/>
-              </a:rPr>
-              <a:t>https://github.com/Beliavsky/TimeSeriesAnalysisBooks</a:t>
-            </a:r>
-            <a:r>
-              <a:rPr lang="ru-RU" dirty="0"/>
-              <a:t> - книги по анализу ВР</a:t>
-            </a:r>
-          </a:p>
-          <a:p>
-            <a:r>
-              <a:rPr lang="en" dirty="0">
-                <a:hlinkClick r:id="rId7"/>
-              </a:rPr>
-              <a:t>https://github.com/Ian729/AI6123-TIME-SERIES-ANALYSIS</a:t>
-            </a:r>
-            <a:r>
-              <a:rPr lang="ru-RU" dirty="0"/>
-              <a:t> - книга по анализу ВР на </a:t>
-            </a:r>
-            <a:r>
-              <a:rPr lang="ru-RU" dirty="0" err="1"/>
-              <a:t>R</a:t>
-            </a:r>
-            <a:r>
-              <a:rPr lang="en-US" dirty="0"/>
-              <a:t> 2015</a:t>
-            </a:r>
-          </a:p>
-          <a:p>
-            <a:r>
-              <a:rPr lang="en" dirty="0">
-                <a:hlinkClick r:id="rId8"/>
-              </a:rPr>
-              <a:t>https://github.com/qingsongedu/awesome-AI-for-time-series-papers</a:t>
-            </a:r>
-            <a:r>
-              <a:rPr lang="en" dirty="0"/>
-              <a:t> - </a:t>
-            </a:r>
-            <a:r>
-              <a:rPr lang="en" dirty="0" err="1"/>
-              <a:t>стат</a:t>
-            </a:r>
-            <a:r>
-              <a:rPr lang="ru-RU" dirty="0" err="1"/>
-              <a:t>ьи</a:t>
-            </a:r>
-            <a:r>
-              <a:rPr lang="ru-RU" dirty="0"/>
-              <a:t> по анализу ВР до 2024</a:t>
-            </a:r>
-          </a:p>
-          <a:p>
-            <a:r>
-              <a:rPr lang="en" dirty="0">
-                <a:hlinkClick r:id="rId9"/>
-              </a:rPr>
-              <a:t>https://github.com/thuml/Time-Series-Library</a:t>
-            </a:r>
-            <a:r>
-              <a:rPr lang="ru-RU" dirty="0"/>
-              <a:t> - Библиотека анализа ВР</a:t>
-            </a:r>
-          </a:p>
-        </p:txBody>
-      </p:sp>
-      <p:sp>
-        <p:nvSpPr>
-          <p:cNvPr id="4" name="Номер слайда 3"/>
-          <p:cNvSpPr>
-            <a:spLocks noGrp="1"/>
-          </p:cNvSpPr>
-          <p:nvPr>
-            <p:ph type="sldNum" sz="quarter" idx="12"/>
-          </p:nvPr>
-        </p:nvSpPr>
-        <p:spPr/>
-        <p:txBody>
-          <a:bodyPr/>
-          <a:lstStyle/>
-          <a:p>
-            <a:fld id="{45C3B737-A709-4ABC-AFE0-A6B067850C48}" type="slidenum">
-              <a:rPr lang="en-US" smtClean="0"/>
-              <a:t>27</a:t>
-            </a:fld>
-            <a:endParaRPr lang="en-US"/>
-          </a:p>
-        </p:txBody>
-      </p:sp>
-    </p:spTree>
-    <p:extLst>
-      <p:ext uri="{BB962C8B-B14F-4D97-AF65-F5344CB8AC3E}">
-        <p14:creationId xmlns:p14="http://schemas.microsoft.com/office/powerpoint/2010/main" val="3703061709"/>
-      </p:ext>
-    </p:extLst>
-  </p:cSld>
-  <p:clrMapOvr>
-    <a:masterClrMapping/>
-  </p:clrMapOvr>
-  <mc:AlternateContent xmlns:mc="http://schemas.openxmlformats.org/markup-compatibility/2006" xmlns:p14="http://schemas.microsoft.com/office/powerpoint/2010/main">
-    <mc:Choice Requires="p14">
-      <p:transition spd="slow" p14:dur="2000"/>
-    </mc:Choice>
-    <mc:Fallback xmlns="">
-      <p:transition spd="slow"/>
-    </mc:Fallback>
-  </mc:AlternateContent>
-</p:sld>
-</file>
-
-<file path=ppt/slides/slide28.xml><?xml version="1.0" encoding="utf-8"?>
-<p:sld xmlns:a="http://schemas.openxmlformats.org/drawingml/2006/main" xmlns:r="http://schemas.openxmlformats.org/officeDocument/2006/relationships" xmlns:p="http://schemas.openxmlformats.org/presentationml/2006/main" show="0">
-  <p:cSld>
-    <p:spTree>
-      <p:nvGrpSpPr>
-        <p:cNvPr id="1" name="">
-          <a:extLst>
-            <a:ext uri="{FF2B5EF4-FFF2-40B4-BE49-F238E27FC236}">
-              <a16:creationId xmlns:a16="http://schemas.microsoft.com/office/drawing/2014/main" id="{0877FD7E-F0AA-12A9-DFB6-74F2303BEEA8}"/>
-            </a:ext>
-          </a:extLst>
-        </p:cNvPr>
-        <p:cNvGrpSpPr/>
-        <p:nvPr/>
-      </p:nvGrpSpPr>
-      <p:grpSpPr>
-        <a:xfrm>
-          <a:off x="0" y="0"/>
-          <a:ext cx="0" cy="0"/>
-          <a:chOff x="0" y="0"/>
-          <a:chExt cx="0" cy="0"/>
-        </a:xfrm>
-      </p:grpSpPr>
-      <p:sp>
-        <p:nvSpPr>
-          <p:cNvPr id="2" name="Заголовок 1">
-            <a:extLst>
-              <a:ext uri="{FF2B5EF4-FFF2-40B4-BE49-F238E27FC236}">
-                <a16:creationId xmlns:a16="http://schemas.microsoft.com/office/drawing/2014/main" id="{90556E89-79CA-50D4-E9BC-0B7C9ACD48D0}"/>
-              </a:ext>
-            </a:extLst>
-          </p:cNvPr>
-          <p:cNvSpPr>
-            <a:spLocks noGrp="1"/>
-          </p:cNvSpPr>
-          <p:nvPr>
-            <p:ph type="title"/>
-          </p:nvPr>
-        </p:nvSpPr>
-        <p:spPr>
-          <a:xfrm>
-            <a:off x="244366" y="365125"/>
-            <a:ext cx="11109434" cy="628103"/>
-          </a:xfrm>
-        </p:spPr>
-        <p:txBody>
-          <a:bodyPr>
-            <a:normAutofit fontScale="90000"/>
-          </a:bodyPr>
-          <a:lstStyle/>
-          <a:p>
-            <a:r>
-              <a:rPr lang="ru-RU" dirty="0"/>
-              <a:t>Литература</a:t>
-            </a:r>
-          </a:p>
-        </p:txBody>
-      </p:sp>
-      <p:sp>
-        <p:nvSpPr>
-          <p:cNvPr id="3" name="Объект 2">
-            <a:extLst>
-              <a:ext uri="{FF2B5EF4-FFF2-40B4-BE49-F238E27FC236}">
-                <a16:creationId xmlns:a16="http://schemas.microsoft.com/office/drawing/2014/main" id="{3FE914B0-07ED-F2EF-0FB4-D73160226B98}"/>
-              </a:ext>
-            </a:extLst>
-          </p:cNvPr>
-          <p:cNvSpPr>
-            <a:spLocks noGrp="1"/>
-          </p:cNvSpPr>
-          <p:nvPr>
-            <p:ph idx="1"/>
-          </p:nvPr>
-        </p:nvSpPr>
-        <p:spPr>
-          <a:xfrm>
-            <a:off x="165538" y="993228"/>
-            <a:ext cx="11737428" cy="5363122"/>
-          </a:xfrm>
-        </p:spPr>
-        <p:txBody>
-          <a:bodyPr/>
-          <a:lstStyle/>
-          <a:p>
-            <a:r>
-              <a:rPr lang="en" b="1" dirty="0"/>
-              <a:t>Forecasting with Python </a:t>
-            </a:r>
-            <a:r>
-              <a:rPr lang="en-US" b="1" dirty="0"/>
-              <a:t>Tutorials </a:t>
-            </a:r>
-            <a:r>
-              <a:rPr lang="en-US" b="1" dirty="0">
-                <a:hlinkClick r:id="rId2"/>
-              </a:rPr>
-              <a:t>https://cienciadedatos.net/en/forecasting-python</a:t>
-            </a:r>
-            <a:endParaRPr lang="ru-RU" b="1" dirty="0"/>
-          </a:p>
-          <a:p>
-            <a:r>
-              <a:rPr lang="en" dirty="0">
-                <a:hlinkClick r:id="rId3"/>
-              </a:rPr>
-              <a:t>https://darrenjw.github.io/time-series/intro.html</a:t>
-            </a:r>
-            <a:endParaRPr lang="en-US" dirty="0"/>
-          </a:p>
-          <a:p>
-            <a:r>
-              <a:rPr lang="en" b="1" dirty="0">
-                <a:hlinkClick r:id="rId4" tooltip="Luminaire"/>
-              </a:rPr>
-              <a:t>Luminaire</a:t>
-            </a:r>
-            <a:r>
-              <a:rPr lang="en" b="1" dirty="0"/>
-              <a:t> </a:t>
-            </a:r>
-            <a:r>
-              <a:rPr lang="en" b="1" dirty="0">
-                <a:hlinkClick r:id="rId5"/>
-              </a:rPr>
-              <a:t>https://zillow.github.io/luminaire/tutorial/dataprofiling.html</a:t>
-            </a:r>
-            <a:r>
-              <a:rPr lang="en" b="1" dirty="0"/>
-              <a:t> </a:t>
-            </a:r>
-            <a:r>
-              <a:rPr lang="en" b="1" dirty="0">
-                <a:hlinkClick r:id="rId6"/>
-              </a:rPr>
-              <a:t>https://medium.com/zillow-tech-hub/automatic-and-self-aware-anomaly-detection-at-zillow-using-luminaire</a:t>
-            </a:r>
-            <a:r>
-              <a:rPr lang="en" b="1" dirty="0"/>
-              <a:t> </a:t>
-            </a:r>
-          </a:p>
-          <a:p>
-            <a:r>
-              <a:rPr lang="en-US" dirty="0">
-                <a:hlinkClick r:id="rId7"/>
-              </a:rPr>
-              <a:t>https://ranalytics.github.io/tsa-with-r/</a:t>
-            </a:r>
-            <a:r>
-              <a:rPr lang="ru-RU" dirty="0"/>
-              <a:t> - </a:t>
-            </a:r>
-            <a:r>
-              <a:rPr lang="ru-RU" dirty="0" err="1"/>
-              <a:t>Аанализ</a:t>
-            </a:r>
-            <a:r>
-              <a:rPr lang="ru-RU" dirty="0"/>
-              <a:t> ВР при помощи </a:t>
-            </a:r>
-            <a:r>
-              <a:rPr lang="en-US" dirty="0"/>
-              <a:t>R</a:t>
-            </a:r>
-            <a:endParaRPr lang="ru-RU" dirty="0"/>
-          </a:p>
-          <a:p>
-            <a:r>
-              <a:rPr lang="en-US" dirty="0">
-                <a:hlinkClick r:id="rId8"/>
-              </a:rPr>
-              <a:t>https://education.yandex.ru/handbook/ml/article/vremennye-ryady</a:t>
-            </a:r>
-            <a:endParaRPr lang="en-US" dirty="0"/>
-          </a:p>
-          <a:p>
-            <a:r>
-              <a:rPr lang="en-US" dirty="0"/>
-              <a:t>https://mrtunguyen.github.io/posts/time-series/time-series.html</a:t>
-            </a:r>
-            <a:r>
-              <a:rPr lang="ru-RU" dirty="0"/>
-              <a:t> </a:t>
-            </a:r>
-            <a:endParaRPr lang="en-US" dirty="0"/>
-          </a:p>
-          <a:p>
-            <a:r>
-              <a:rPr lang="en-US" dirty="0"/>
-              <a:t>https://dev.mrdbourke.com/tensorflow-deep-learning/10_time_series_forecasting_in_tensorflow/</a:t>
-            </a:r>
-            <a:endParaRPr lang="ru-RU" dirty="0"/>
-          </a:p>
-        </p:txBody>
-      </p:sp>
-      <p:sp>
-        <p:nvSpPr>
-          <p:cNvPr id="4" name="Номер слайда 3">
-            <a:extLst>
-              <a:ext uri="{FF2B5EF4-FFF2-40B4-BE49-F238E27FC236}">
-                <a16:creationId xmlns:a16="http://schemas.microsoft.com/office/drawing/2014/main" id="{FD8E627C-3E57-8991-44CD-2D8C81307B55}"/>
-              </a:ext>
-            </a:extLst>
-          </p:cNvPr>
-          <p:cNvSpPr>
-            <a:spLocks noGrp="1"/>
-          </p:cNvSpPr>
-          <p:nvPr>
-            <p:ph type="sldNum" sz="quarter" idx="12"/>
-          </p:nvPr>
-        </p:nvSpPr>
-        <p:spPr/>
-        <p:txBody>
-          <a:bodyPr/>
-          <a:lstStyle/>
-          <a:p>
-            <a:fld id="{45C3B737-A709-4ABC-AFE0-A6B067850C48}" type="slidenum">
-              <a:rPr lang="en-US" smtClean="0"/>
-              <a:t>28</a:t>
-            </a:fld>
-            <a:endParaRPr lang="en-US"/>
-          </a:p>
-        </p:txBody>
-      </p:sp>
-    </p:spTree>
-    <p:extLst>
-      <p:ext uri="{BB962C8B-B14F-4D97-AF65-F5344CB8AC3E}">
-        <p14:creationId xmlns:p14="http://schemas.microsoft.com/office/powerpoint/2010/main" val="1998022513"/>
-      </p:ext>
-    </p:extLst>
-  </p:cSld>
-  <p:clrMapOvr>
-    <a:masterClrMapping/>
-  </p:clrMapOvr>
-  <mc:AlternateContent xmlns:mc="http://schemas.openxmlformats.org/markup-compatibility/2006" xmlns:p14="http://schemas.microsoft.com/office/powerpoint/2010/main">
-    <mc:Choice Requires="p14">
-      <p:transition spd="slow" p14:dur="2000"/>
-    </mc:Choice>
-    <mc:Fallback xmlns="">
-      <p:transition spd="slow"/>
-    </mc:Fallback>
-  </mc:AlternateContent>
-</p:sld>
-</file>
-
-<file path=ppt/slides/slide29.xml><?xml version="1.0" encoding="utf-8"?>
-<p:sld xmlns:a="http://schemas.openxmlformats.org/drawingml/2006/main" xmlns:r="http://schemas.openxmlformats.org/officeDocument/2006/relationships" xmlns:p="http://schemas.openxmlformats.org/presentationml/2006/main" show="0">
-  <p:cSld>
-    <p:spTree>
-      <p:nvGrpSpPr>
-        <p:cNvPr id="1" name=""/>
-        <p:cNvGrpSpPr/>
-        <p:nvPr/>
-      </p:nvGrpSpPr>
-      <p:grpSpPr>
-        <a:xfrm>
-          <a:off x="0" y="0"/>
-          <a:ext cx="0" cy="0"/>
-          <a:chOff x="0" y="0"/>
-          <a:chExt cx="0" cy="0"/>
-        </a:xfrm>
-      </p:grpSpPr>
-      <p:sp>
-        <p:nvSpPr>
-          <p:cNvPr id="2" name="Заголовок 1">
-            <a:extLst>
-              <a:ext uri="{FF2B5EF4-FFF2-40B4-BE49-F238E27FC236}">
-                <a16:creationId xmlns:a16="http://schemas.microsoft.com/office/drawing/2014/main" id="{07318AB3-6E97-3C2A-02C0-D8613E9CEC41}"/>
-              </a:ext>
-            </a:extLst>
-          </p:cNvPr>
-          <p:cNvSpPr>
-            <a:spLocks noGrp="1"/>
-          </p:cNvSpPr>
-          <p:nvPr>
-            <p:ph type="title"/>
-          </p:nvPr>
-        </p:nvSpPr>
-        <p:spPr/>
-        <p:txBody>
-          <a:bodyPr/>
-          <a:lstStyle/>
-          <a:p>
-            <a:endParaRPr lang="ru-RU"/>
-          </a:p>
-        </p:txBody>
-      </p:sp>
-      <p:sp>
-        <p:nvSpPr>
-          <p:cNvPr id="3" name="Объект 2">
-            <a:extLst>
-              <a:ext uri="{FF2B5EF4-FFF2-40B4-BE49-F238E27FC236}">
-                <a16:creationId xmlns:a16="http://schemas.microsoft.com/office/drawing/2014/main" id="{FFF0A1DB-D463-436A-1DC0-D039706631DE}"/>
-              </a:ext>
-            </a:extLst>
-          </p:cNvPr>
-          <p:cNvSpPr>
-            <a:spLocks noGrp="1"/>
-          </p:cNvSpPr>
-          <p:nvPr>
-            <p:ph idx="1"/>
-          </p:nvPr>
-        </p:nvSpPr>
-        <p:spPr>
-          <a:xfrm>
-            <a:off x="838200" y="1825624"/>
-            <a:ext cx="11118156" cy="4530725"/>
-          </a:xfrm>
-        </p:spPr>
-        <p:txBody>
-          <a:bodyPr>
-            <a:normAutofit fontScale="92500" lnSpcReduction="10000"/>
-          </a:bodyPr>
-          <a:lstStyle/>
-          <a:p>
-            <a:r>
-              <a:rPr lang="en" dirty="0">
-                <a:hlinkClick r:id="rId2"/>
-              </a:rPr>
-              <a:t>https://github.com/unit8co/darts</a:t>
-            </a:r>
-            <a:endParaRPr lang="en" dirty="0"/>
-          </a:p>
-          <a:p>
-            <a:r>
-              <a:rPr lang="en" dirty="0" err="1"/>
-              <a:t>Skforecast</a:t>
-            </a:r>
-            <a:r>
-              <a:rPr lang="en" dirty="0"/>
-              <a:t> </a:t>
-            </a:r>
-            <a:r>
-              <a:rPr lang="en" dirty="0">
-                <a:hlinkClick r:id="rId3"/>
-              </a:rPr>
-              <a:t>https://skforecast.org/0.16.0/</a:t>
-            </a:r>
-            <a:r>
-              <a:rPr lang="en" dirty="0"/>
-              <a:t>  </a:t>
-            </a:r>
-            <a:r>
-              <a:rPr lang="en" dirty="0">
-                <a:hlinkClick r:id="rId4"/>
-              </a:rPr>
-              <a:t>https://cienciadedatos.net/en/forecasting-python</a:t>
-            </a:r>
-            <a:r>
-              <a:rPr lang="en" dirty="0"/>
-              <a:t> </a:t>
-            </a:r>
-          </a:p>
-          <a:p>
-            <a:r>
-              <a:rPr lang="en" dirty="0">
-                <a:hlinkClick r:id="rId5"/>
-              </a:rPr>
-              <a:t>https://github.com/linhhlp/Scalable-Machine-Learning-for-Small-Teams/</a:t>
-            </a:r>
-            <a:r>
-              <a:rPr lang="ru-RU" dirty="0"/>
-              <a:t> </a:t>
-            </a:r>
-            <a:endParaRPr lang="en-US" dirty="0"/>
-          </a:p>
-          <a:p>
-            <a:r>
-              <a:rPr lang="en" dirty="0">
-                <a:hlinkClick r:id="rId6"/>
-              </a:rPr>
-              <a:t>https://robjhyndman.com/hyndsight/python_time_series.html</a:t>
-            </a:r>
-            <a:r>
-              <a:rPr lang="en" dirty="0"/>
-              <a:t> - </a:t>
-            </a:r>
-            <a:r>
-              <a:rPr lang="ru-RU" dirty="0"/>
-              <a:t>обзор реализаций методов на </a:t>
-            </a:r>
-            <a:r>
-              <a:rPr lang="en-US" dirty="0"/>
-              <a:t>python</a:t>
-            </a:r>
-          </a:p>
-          <a:p>
-            <a:r>
-              <a:rPr lang="en-US" dirty="0">
-                <a:hlinkClick r:id="rId7"/>
-              </a:rPr>
-              <a:t>https://openforecast.org/adam/</a:t>
-            </a:r>
-            <a:endParaRPr lang="en-US" dirty="0"/>
-          </a:p>
-          <a:p>
-            <a:r>
-              <a:rPr lang="en-US" dirty="0">
-                <a:hlinkClick r:id="rId8"/>
-              </a:rPr>
-              <a:t>https://github.com/qingsongedu/awesome-AI-for-time-series-papers</a:t>
-            </a:r>
-            <a:endParaRPr lang="en-US" dirty="0"/>
-          </a:p>
-          <a:p>
-            <a:r>
-              <a:rPr lang="en-US" dirty="0">
-                <a:hlinkClick r:id="rId9"/>
-              </a:rPr>
-              <a:t>https://www.sciencedirect.com/science/article/pii/S0169207021001758</a:t>
-            </a:r>
-            <a:r>
-              <a:rPr lang="en-US" dirty="0"/>
-              <a:t> </a:t>
-            </a:r>
-            <a:endParaRPr lang="ru-RU" dirty="0"/>
-          </a:p>
-          <a:p>
-            <a:r>
-              <a:rPr lang="en-US" dirty="0">
-                <a:hlinkClick r:id="rId10"/>
-              </a:rPr>
-              <a:t>http://repo.darmajaya.ac.id/4781/1/Time%20Series%20Analysis_%20Forecasting%20and%20Control%20%28%20PDFDrive%20%29.pdf</a:t>
-            </a:r>
-            <a:r>
-              <a:rPr lang="ru-RU"/>
-              <a:t> </a:t>
-            </a:r>
-            <a:r>
-              <a:rPr lang="en-US"/>
-              <a:t> </a:t>
-            </a:r>
-            <a:endParaRPr lang="ru-RU" dirty="0"/>
-          </a:p>
-        </p:txBody>
-      </p:sp>
-      <p:sp>
-        <p:nvSpPr>
-          <p:cNvPr id="4" name="Номер слайда 3">
-            <a:extLst>
-              <a:ext uri="{FF2B5EF4-FFF2-40B4-BE49-F238E27FC236}">
-                <a16:creationId xmlns:a16="http://schemas.microsoft.com/office/drawing/2014/main" id="{1771163D-FA5C-9021-4321-63063D1A5F40}"/>
-              </a:ext>
-            </a:extLst>
-          </p:cNvPr>
-          <p:cNvSpPr>
-            <a:spLocks noGrp="1"/>
-          </p:cNvSpPr>
-          <p:nvPr>
-            <p:ph type="sldNum" sz="quarter" idx="12"/>
-          </p:nvPr>
-        </p:nvSpPr>
-        <p:spPr/>
-        <p:txBody>
-          <a:bodyPr/>
-          <a:lstStyle/>
-          <a:p>
-            <a:fld id="{45C3B737-A709-4ABC-AFE0-A6B067850C48}" type="slidenum">
-              <a:rPr lang="en-US" smtClean="0"/>
-              <a:t>29</a:t>
-            </a:fld>
-            <a:endParaRPr lang="en-US"/>
-          </a:p>
-        </p:txBody>
-      </p:sp>
-    </p:spTree>
-    <p:extLst>
-      <p:ext uri="{BB962C8B-B14F-4D97-AF65-F5344CB8AC3E}">
-        <p14:creationId xmlns:p14="http://schemas.microsoft.com/office/powerpoint/2010/main" val="4198558770"/>
       </p:ext>
     </p:extLst>
   </p:cSld>
@@ -14020,327 +13444,6 @@
   <p:clrMapOvr>
     <a:masterClrMapping/>
   </p:clrMapOvr>
-</p:sld>
-</file>
-
-<file path=ppt/slides/slide30.xml><?xml version="1.0" encoding="utf-8"?>
-<p:sld xmlns:a="http://schemas.openxmlformats.org/drawingml/2006/main" xmlns:r="http://schemas.openxmlformats.org/officeDocument/2006/relationships" xmlns:p="http://schemas.openxmlformats.org/presentationml/2006/main" show="0">
-  <p:cSld>
-    <p:spTree>
-      <p:nvGrpSpPr>
-        <p:cNvPr id="1" name="">
-          <a:extLst>
-            <a:ext uri="{FF2B5EF4-FFF2-40B4-BE49-F238E27FC236}">
-              <a16:creationId xmlns:a16="http://schemas.microsoft.com/office/drawing/2014/main" id="{14E7A2F7-0290-7993-222E-F9163CC02F75}"/>
-            </a:ext>
-          </a:extLst>
-        </p:cNvPr>
-        <p:cNvGrpSpPr/>
-        <p:nvPr/>
-      </p:nvGrpSpPr>
-      <p:grpSpPr>
-        <a:xfrm>
-          <a:off x="0" y="0"/>
-          <a:ext cx="0" cy="0"/>
-          <a:chOff x="0" y="0"/>
-          <a:chExt cx="0" cy="0"/>
-        </a:xfrm>
-      </p:grpSpPr>
-      <p:sp>
-        <p:nvSpPr>
-          <p:cNvPr id="2" name="Заголовок 1">
-            <a:extLst>
-              <a:ext uri="{FF2B5EF4-FFF2-40B4-BE49-F238E27FC236}">
-                <a16:creationId xmlns:a16="http://schemas.microsoft.com/office/drawing/2014/main" id="{AE94F084-846D-1E20-6379-EEC305C89778}"/>
-              </a:ext>
-            </a:extLst>
-          </p:cNvPr>
-          <p:cNvSpPr>
-            <a:spLocks noGrp="1"/>
-          </p:cNvSpPr>
-          <p:nvPr>
-            <p:ph type="title"/>
-          </p:nvPr>
-        </p:nvSpPr>
-        <p:spPr/>
-        <p:txBody>
-          <a:bodyPr/>
-          <a:lstStyle/>
-          <a:p>
-            <a:endParaRPr lang="ru-RU"/>
-          </a:p>
-        </p:txBody>
-      </p:sp>
-      <p:sp>
-        <p:nvSpPr>
-          <p:cNvPr id="3" name="Объект 2">
-            <a:extLst>
-              <a:ext uri="{FF2B5EF4-FFF2-40B4-BE49-F238E27FC236}">
-                <a16:creationId xmlns:a16="http://schemas.microsoft.com/office/drawing/2014/main" id="{CD16A171-2167-F8EC-A7E3-1183CFD0AF9A}"/>
-              </a:ext>
-            </a:extLst>
-          </p:cNvPr>
-          <p:cNvSpPr>
-            <a:spLocks noGrp="1"/>
-          </p:cNvSpPr>
-          <p:nvPr>
-            <p:ph idx="1"/>
-          </p:nvPr>
-        </p:nvSpPr>
-        <p:spPr>
-          <a:xfrm>
-            <a:off x="695325" y="1847849"/>
-            <a:ext cx="10515600" cy="4873625"/>
-          </a:xfrm>
-        </p:spPr>
-        <p:txBody>
-          <a:bodyPr>
-            <a:normAutofit fontScale="47500" lnSpcReduction="20000"/>
-          </a:bodyPr>
-          <a:lstStyle/>
-          <a:p>
-            <a:r>
-              <a:rPr lang="en" dirty="0">
-                <a:hlinkClick r:id="rId2"/>
-              </a:rPr>
-              <a:t>https://www.statslab.cam.ac.uk/~rrw1/timeseries/t.pdf</a:t>
-            </a:r>
-            <a:r>
-              <a:rPr lang="en" dirty="0"/>
-              <a:t> </a:t>
-            </a:r>
-          </a:p>
-          <a:p>
-            <a:r>
-              <a:rPr lang="en" dirty="0">
-                <a:hlinkClick r:id="rId3"/>
-              </a:rPr>
-              <a:t>https://s-ai-f.github.io/Time-Series/time-series-basics.html#what-is-a-time-series</a:t>
-            </a:r>
-            <a:r>
-              <a:rPr lang="en" dirty="0"/>
-              <a:t> </a:t>
-            </a:r>
-          </a:p>
-          <a:p>
-            <a:r>
-              <a:rPr lang="en" dirty="0">
-                <a:hlinkClick r:id="rId4"/>
-              </a:rPr>
-              <a:t>https://bookdown.org/JakeEsprabens/431-Time-Series/forecasting.html</a:t>
-            </a:r>
-            <a:r>
-              <a:rPr lang="en" dirty="0"/>
-              <a:t> </a:t>
-            </a:r>
-          </a:p>
-          <a:p>
-            <a:r>
-              <a:rPr lang="en" dirty="0">
-                <a:hlinkClick r:id="rId5"/>
-              </a:rPr>
-              <a:t>https://smac-group.github.io/ts/fundtimeseries.html</a:t>
-            </a:r>
-            <a:r>
-              <a:rPr lang="en" dirty="0"/>
-              <a:t> </a:t>
-            </a:r>
-          </a:p>
-          <a:p>
-            <a:r>
-              <a:rPr lang="en" dirty="0">
-                <a:hlinkClick r:id="rId6"/>
-              </a:rPr>
-              <a:t>https://civil.colorado.edu/~balajir/CVEN6833/lectures/wwts-book.pdf</a:t>
-            </a:r>
-            <a:r>
-              <a:rPr lang="en" dirty="0"/>
-              <a:t> </a:t>
-            </a:r>
-            <a:endParaRPr lang="ru-RU" dirty="0"/>
-          </a:p>
-          <a:p>
-            <a:r>
-              <a:rPr lang="en" dirty="0">
-                <a:hlinkClick r:id="rId7"/>
-              </a:rPr>
-              <a:t>https://mse.msu.ru/wp-content/uploads/2021/03/%D0%92%D0%B2%D0%B5%D0%B4%D0%B5%D0%BD%D0%B8%D0%B5-%D0%B2-%D0%B0%D0%BD%D0%B0%D0%BB%D0%B8%D0%B7-%D0%B2%D1%80%D0%B5%D0%BC%D0%B5%D0%BD%D0%BD%D1%8B%D1%85-%D1%80%D1%8F%D0%B4%D0%BE%D0%B2-1.pdf</a:t>
-            </a:r>
-            <a:r>
-              <a:rPr lang="ru-RU" dirty="0"/>
-              <a:t> </a:t>
-            </a:r>
-          </a:p>
-          <a:p>
-            <a:r>
-              <a:rPr lang="en" dirty="0">
-                <a:hlinkClick r:id="rId8"/>
-              </a:rPr>
-              <a:t>https://dl.leima.is/time-series/</a:t>
-            </a:r>
-            <a:endParaRPr lang="en" dirty="0"/>
-          </a:p>
-          <a:p>
-            <a:r>
-              <a:rPr lang="en-US" dirty="0">
-                <a:hlinkClick r:id="rId9"/>
-              </a:rPr>
-              <a:t>https://www.kaggle.com/code/prashant111/complete-guide-on-time-series-analysis-in-python</a:t>
-            </a:r>
-            <a:r>
-              <a:rPr lang="en-US" dirty="0"/>
-              <a:t> </a:t>
-            </a:r>
-            <a:endParaRPr lang="ru-RU" dirty="0"/>
-          </a:p>
-          <a:p>
-            <a:r>
-              <a:rPr lang="en-US" dirty="0">
-                <a:hlinkClick r:id="rId10"/>
-              </a:rPr>
-              <a:t>https://medium.com/data-science-at-microsoft/time-series-forecasting-part-3-of-3-introducing-auts-adaptive-univariate-time-series-dfd7555ca8d4</a:t>
-            </a:r>
-            <a:endParaRPr lang="ru-RU" dirty="0"/>
-          </a:p>
-          <a:p>
-            <a:r>
-              <a:rPr lang="en-US" dirty="0">
-                <a:hlinkClick r:id="rId11"/>
-              </a:rPr>
-              <a:t>https://www.openforecast.org/adam/state-space-form-of-ets.html</a:t>
-            </a:r>
-            <a:endParaRPr lang="ru-RU" dirty="0"/>
-          </a:p>
-          <a:p>
-            <a:r>
-              <a:rPr lang="en-US" dirty="0">
-                <a:hlinkClick r:id="rId12"/>
-              </a:rPr>
-              <a:t>https://livebook.manning.com/book/modern-time-series-analysis-in-python/c</a:t>
-            </a:r>
-            <a:r>
-              <a:rPr lang="ru-RU" dirty="0"/>
-              <a:t> </a:t>
-            </a:r>
-          </a:p>
-          <a:p>
-            <a:r>
-              <a:rPr lang="en-US" dirty="0">
-                <a:hlinkClick r:id="rId13"/>
-              </a:rPr>
-              <a:t>https://ranalytics.github.io/tsa-with-r/</a:t>
-            </a:r>
-            <a:r>
-              <a:rPr lang="ru-RU" dirty="0"/>
-              <a:t> </a:t>
-            </a:r>
-            <a:endParaRPr lang="en-US" dirty="0"/>
-          </a:p>
-          <a:p>
-            <a:r>
-              <a:rPr lang="en-US" dirty="0">
-                <a:hlinkClick r:id="rId14"/>
-              </a:rPr>
-              <a:t>https://towardsdatascience.com/forecast-multiple-time-series-like-a-master-1579a2b6f18d/</a:t>
-            </a:r>
-            <a:r>
-              <a:rPr lang="en-US" dirty="0"/>
-              <a:t> </a:t>
-            </a:r>
-          </a:p>
-          <a:p>
-            <a:r>
-              <a:rPr lang="en-US" dirty="0">
-                <a:hlinkClick r:id="rId15"/>
-              </a:rPr>
-              <a:t>https://www.stat.berkeley.edu/~aditya/resources/FullNotes248Spring2022TimeSeries.pdf</a:t>
-            </a:r>
-            <a:endParaRPr lang="en-US" dirty="0"/>
-          </a:p>
-          <a:p>
-            <a:r>
-              <a:rPr lang="en-US" dirty="0">
-                <a:hlinkClick r:id="rId16"/>
-              </a:rPr>
-              <a:t>https://www.stat.berkeley.edu/~ryantibs/timeseries-f23/</a:t>
-            </a:r>
-            <a:endParaRPr lang="ru-RU" dirty="0"/>
-          </a:p>
-          <a:p>
-            <a:r>
-              <a:rPr lang="en-US" dirty="0">
-                <a:hlinkClick r:id="rId17"/>
-              </a:rPr>
-              <a:t>https://stat153.berkeley.edu/spring-2025/lab5</a:t>
-            </a:r>
-            <a:r>
-              <a:rPr lang="ru-RU" dirty="0"/>
-              <a:t> - интерактивно</a:t>
-            </a:r>
-            <a:endParaRPr lang="en-US" dirty="0"/>
-          </a:p>
-          <a:p>
-            <a:r>
-              <a:rPr lang="en" dirty="0">
-                <a:hlinkClick r:id="rId18"/>
-              </a:rPr>
-              <a:t>https://fish-forecast.github.io/Fish-Forecast-Bookdown/</a:t>
-            </a:r>
-            <a:r>
-              <a:rPr lang="en" dirty="0"/>
-              <a:t> </a:t>
-            </a:r>
-            <a:endParaRPr lang="ru-RU" dirty="0"/>
-          </a:p>
-        </p:txBody>
-      </p:sp>
-      <p:sp>
-        <p:nvSpPr>
-          <p:cNvPr id="4" name="Номер слайда 3">
-            <a:extLst>
-              <a:ext uri="{FF2B5EF4-FFF2-40B4-BE49-F238E27FC236}">
-                <a16:creationId xmlns:a16="http://schemas.microsoft.com/office/drawing/2014/main" id="{601C3A2C-73D2-5BF6-4450-5C867B5B8439}"/>
-              </a:ext>
-            </a:extLst>
-          </p:cNvPr>
-          <p:cNvSpPr>
-            <a:spLocks noGrp="1"/>
-          </p:cNvSpPr>
-          <p:nvPr>
-            <p:ph type="sldNum" sz="quarter" idx="12"/>
-          </p:nvPr>
-        </p:nvSpPr>
-        <p:spPr/>
-        <p:txBody>
-          <a:bodyPr/>
-          <a:lstStyle/>
-          <a:p>
-            <a:fld id="{45C3B737-A709-4ABC-AFE0-A6B067850C48}" type="slidenum">
-              <a:rPr lang="en-US" smtClean="0"/>
-              <a:t>30</a:t>
-            </a:fld>
-            <a:endParaRPr lang="en-US"/>
-          </a:p>
-        </p:txBody>
-      </p:sp>
-    </p:spTree>
-    <p:extLst>
-      <p:ext uri="{BB962C8B-B14F-4D97-AF65-F5344CB8AC3E}">
-        <p14:creationId xmlns:p14="http://schemas.microsoft.com/office/powerpoint/2010/main" val="535373884"/>
-      </p:ext>
-    </p:extLst>
-  </p:cSld>
-  <p:clrMapOvr>
-    <a:masterClrMapping/>
-  </p:clrMapOvr>
-  <mc:AlternateContent xmlns:mc="http://schemas.openxmlformats.org/markup-compatibility/2006" xmlns:p14="http://schemas.microsoft.com/office/powerpoint/2010/main">
-    <mc:Choice Requires="p14">
-      <p:transition spd="slow" p14:dur="2000"/>
-    </mc:Choice>
-    <mc:Fallback xmlns="">
-      <p:transition spd="slow"/>
-    </mc:Fallback>
-  </mc:AlternateContent>
 </p:sld>
 </file>
 

</xml_diff>